<commit_message>
slides: link C2 and C3 references to original papers
</commit_message>
<xml_diff>
--- a/platform/site/demos/downloads/music-rl-tables-2026-10-15-C.pptx
+++ b/platform/site/demos/downloads/music-rl-tables-2026-10-15-C.pptx
@@ -2,15 +2,15 @@
 <file path=ppt/presentation.xml><?xml version="1.0" encoding="utf-8"?>
 <p:presentation xmlns:p="http://schemas.openxmlformats.org/presentationml/2006/main">
   <p:sldMasterIdLst>
-    <p:sldMasterId xmlns:r="http://schemas.openxmlformats.org/officeDocument/2006/relationships" id="2147483648" r:id="R74ebf1f45df54605"/>
+    <p:sldMasterId xmlns:r="http://schemas.openxmlformats.org/officeDocument/2006/relationships" id="2147483648" r:id="R8c0e4646928c476a"/>
   </p:sldMasterIdLst>
   <p:notesMasterIdLst>
-    <p:notesMasterId xmlns:r="http://schemas.openxmlformats.org/officeDocument/2006/relationships" r:id="Rbdfdbcd9a29b4333"/>
+    <p:notesMasterId xmlns:r="http://schemas.openxmlformats.org/officeDocument/2006/relationships" r:id="R740f9aaa0494481c"/>
   </p:notesMasterIdLst>
   <p:sldIdLst>
-    <p:sldId xmlns:r="http://schemas.openxmlformats.org/officeDocument/2006/relationships" id="256" r:id="R37d2772f147e4e9e"/>
-    <p:sldId xmlns:r="http://schemas.openxmlformats.org/officeDocument/2006/relationships" id="257" r:id="R05851f3b42964d0f"/>
-    <p:sldId xmlns:r="http://schemas.openxmlformats.org/officeDocument/2006/relationships" id="258" r:id="Rb3e953567ebe4706"/>
+    <p:sldId xmlns:r="http://schemas.openxmlformats.org/officeDocument/2006/relationships" id="256" r:id="Ra7a80a1601044e91"/>
+    <p:sldId xmlns:r="http://schemas.openxmlformats.org/officeDocument/2006/relationships" id="257" r:id="R3347a48df0b9468a"/>
+    <p:sldId xmlns:r="http://schemas.openxmlformats.org/officeDocument/2006/relationships" id="258" r:id="Rfe7ff9b156ce4c58"/>
   </p:sldIdLst>
   <p:sldSz cx="18288000" cy="10287000"/>
   <p:notesSz cx="6858000" cy="9144000"/>
@@ -5257,12 +5257,12 @@
   </p:cSld>
   <p:clrMap bg1="lt1" tx1="dk1" bg2="lt2" tx2="dk2" accent1="accent1" accent2="accent2" accent3="accent3" accent4="accent4" accent5="accent5" accent6="accent6" hlink="hlink" folHlink="folHlink"/>
   <p:sldLayoutIdLst>
-    <p:sldLayoutId xmlns:r="http://schemas.openxmlformats.org/officeDocument/2006/relationships" id="2147483649" r:id="R4d688e95d84f4d39"/>
-    <p:sldLayoutId xmlns:r="http://schemas.openxmlformats.org/officeDocument/2006/relationships" id="2147483650" r:id="Ra6992ef3cb484b66"/>
-    <p:sldLayoutId xmlns:r="http://schemas.openxmlformats.org/officeDocument/2006/relationships" id="2147483651" r:id="R7dfe179a41ea40ec"/>
-    <p:sldLayoutId xmlns:r="http://schemas.openxmlformats.org/officeDocument/2006/relationships" id="2147483652" r:id="R8b71c9d7ec184556"/>
-    <p:sldLayoutId xmlns:r="http://schemas.openxmlformats.org/officeDocument/2006/relationships" id="2147483653" r:id="Ra0f61994a7544ec9"/>
-    <p:sldLayoutId xmlns:r="http://schemas.openxmlformats.org/officeDocument/2006/relationships" id="2147483654" r:id="Rc948a0a4717f4c6b"/>
+    <p:sldLayoutId xmlns:r="http://schemas.openxmlformats.org/officeDocument/2006/relationships" id="2147483649" r:id="R42a4811b282b48be"/>
+    <p:sldLayoutId xmlns:r="http://schemas.openxmlformats.org/officeDocument/2006/relationships" id="2147483650" r:id="Rc90f300a49f04a79"/>
+    <p:sldLayoutId xmlns:r="http://schemas.openxmlformats.org/officeDocument/2006/relationships" id="2147483651" r:id="Rab05508e87e34c6f"/>
+    <p:sldLayoutId xmlns:r="http://schemas.openxmlformats.org/officeDocument/2006/relationships" id="2147483652" r:id="R7c6865e7eb494690"/>
+    <p:sldLayoutId xmlns:r="http://schemas.openxmlformats.org/officeDocument/2006/relationships" id="2147483653" r:id="R20d2257403804460"/>
+    <p:sldLayoutId xmlns:r="http://schemas.openxmlformats.org/officeDocument/2006/relationships" id="2147483654" r:id="R190f15f1c0fe4020"/>
   </p:sldLayoutIdLst>
   <p:txStyles>
     <p:titleStyle>
@@ -6105,7 +6105,7 @@
           <p:cNvPr id="5" name="">
             <a:extLst xmlns:a="http://schemas.openxmlformats.org/drawingml/2006/main">
               <a:ext uri="{FF2B5EF4-FFF2-40B4-BE49-F238E27FC236}">
-                <a16:creationId xmlns:a16="http://schemas.microsoft.com/office/drawing/2014/main" id="{1B2A682B-8C3D-49DA-BF12-D8FFE99EE7CE}"/>
+                <a16:creationId xmlns:a16="http://schemas.microsoft.com/office/drawing/2014/main" id="{2BB57CA0-79AA-4616-A384-7F9D0B707C77}"/>
               </a:ext>
             </a:extLst>
           </p:cNvPr>
@@ -10810,7 +10810,7 @@
           <p:cNvPr id="5" name="">
             <a:extLst xmlns:a="http://schemas.openxmlformats.org/drawingml/2006/main">
               <a:ext uri="{FF2B5EF4-FFF2-40B4-BE49-F238E27FC236}">
-                <a16:creationId xmlns:a16="http://schemas.microsoft.com/office/drawing/2014/main" id="{8FD732B2-1680-48DE-B7B5-5D108E9474BF}"/>
+                <a16:creationId xmlns:a16="http://schemas.microsoft.com/office/drawing/2014/main" id="{9C4E523D-CCE1-496E-8A32-5D136E68412F}"/>
               </a:ext>
             </a:extLst>
           </p:cNvPr>
@@ -11296,30 +11296,66 @@
                       <a:r>
                         <a:rPr sz="1763" b="0">
                           <a:solidFill>
+                            <a:srgbClr val="245D8C"/>
+                          </a:solidFill>
+                          <a:latin typeface="Hiragino Sans GB"/>
+                          <a:ea typeface="Hiragino Sans GB"/>
+                          <a:cs typeface="Hiragino Sans GB"/>
+                          <a:hlinkClick xmlns:r="http://schemas.openxmlformats.org/officeDocument/2006/relationships" r:id="Rbbbbe35c393e4374"/>
+                        </a:rPr>
+                        <a:t>LeVo 2</a:t>
+                      </a:r>
+                      <a:r>
+                        <a:rPr sz="1763" b="0">
+                          <a:solidFill>
                             <a:srgbClr val="202832"/>
                           </a:solidFill>
                           <a:latin typeface="Hiragino Sans GB"/>
                           <a:ea typeface="Hiragino Sans GB"/>
                           <a:cs typeface="Hiragino Sans GB"/>
                         </a:rPr>
-                        <a:t>LeVo 2；HeartMuLa；</a:t>
-                      </a:r>
-                    </a:p>
-                    <a:p>
-                      <a:pPr algn="l">
-                        <a:lnSpc>
-                          <a:spcPct val="103000"/>
-                        </a:lnSpc>
-                        <a:buNone/>
-                      </a:pPr>
+                        <a:t>；</a:t>
+                      </a:r>
                       <a:r>
                         <a:rPr sz="1763" b="0">
                           <a:solidFill>
+                            <a:srgbClr val="245D8C"/>
+                          </a:solidFill>
+                          <a:latin typeface="Hiragino Sans GB"/>
+                          <a:ea typeface="Hiragino Sans GB"/>
+                          <a:cs typeface="Hiragino Sans GB"/>
+                          <a:hlinkClick xmlns:r="http://schemas.openxmlformats.org/officeDocument/2006/relationships" r:id="R8c78025c00844149"/>
+                        </a:rPr>
+                        <a:t>HeartMuLa</a:t>
+                      </a:r>
+                      <a:r>
+                        <a:rPr sz="1763" b="0">
+                          <a:solidFill>
                             <a:srgbClr val="202832"/>
                           </a:solidFill>
                           <a:latin typeface="Hiragino Sans GB"/>
                           <a:ea typeface="Hiragino Sans GB"/>
                           <a:cs typeface="Hiragino Sans GB"/>
+                        </a:rPr>
+                        <a:t>；</a:t>
+                      </a:r>
+                    </a:p>
+                    <a:p>
+                      <a:pPr algn="l">
+                        <a:lnSpc>
+                          <a:spcPct val="103000"/>
+                        </a:lnSpc>
+                        <a:buNone/>
+                      </a:pPr>
+                      <a:r>
+                        <a:rPr sz="1763" b="0">
+                          <a:solidFill>
+                            <a:srgbClr val="245D8C"/>
+                          </a:solidFill>
+                          <a:latin typeface="Hiragino Sans GB"/>
+                          <a:ea typeface="Hiragino Sans GB"/>
+                          <a:cs typeface="Hiragino Sans GB"/>
+                          <a:hlinkClick xmlns:r="http://schemas.openxmlformats.org/officeDocument/2006/relationships" r:id="R9f02e6d67ff24b96"/>
                         </a:rPr>
                         <a:t>FullSong</a:t>
                       </a:r>
@@ -11593,7 +11629,19 @@
                           <a:ea typeface="Hiragino Sans GB"/>
                           <a:cs typeface="Hiragino Sans GB"/>
                         </a:rPr>
-                        <a:t>可借鉴SVS旋律/歌词奖励</a:t>
+                        <a:t>可借鉴</a:t>
+                      </a:r>
+                      <a:r>
+                        <a:rPr sz="1763" b="0">
+                          <a:solidFill>
+                            <a:srgbClr val="245D8C"/>
+                          </a:solidFill>
+                          <a:latin typeface="Hiragino Sans GB"/>
+                          <a:ea typeface="Hiragino Sans GB"/>
+                          <a:cs typeface="Hiragino Sans GB"/>
+                          <a:hlinkClick xmlns:r="http://schemas.openxmlformats.org/officeDocument/2006/relationships" r:id="Reea8a6dd7ad94aa2"/>
+                        </a:rPr>
+                        <a:t>SVS旋律/歌词奖励</a:t>
                       </a:r>
                     </a:p>
                   </a:txBody>
@@ -11859,13 +11907,25 @@
                       <a:r>
                         <a:rPr sz="1763" b="0">
                           <a:solidFill>
+                            <a:srgbClr val="245D8C"/>
+                          </a:solidFill>
+                          <a:latin typeface="Hiragino Sans GB"/>
+                          <a:ea typeface="Hiragino Sans GB"/>
+                          <a:cs typeface="Hiragino Sans GB"/>
+                          <a:hlinkClick xmlns:r="http://schemas.openxmlformats.org/officeDocument/2006/relationships" r:id="R5c57e92e93534117"/>
+                        </a:rPr>
+                        <a:t>HeartMuLa</a:t>
+                      </a:r>
+                      <a:r>
+                        <a:rPr sz="1763" b="0">
+                          <a:solidFill>
                             <a:srgbClr val="202832"/>
                           </a:solidFill>
                           <a:latin typeface="Hiragino Sans GB"/>
                           <a:ea typeface="Hiragino Sans GB"/>
                           <a:cs typeface="Hiragino Sans GB"/>
                         </a:rPr>
-                        <a:t>HeartMuLa；</a:t>
+                        <a:t>；</a:t>
                       </a:r>
                     </a:p>
                     <a:p>
@@ -11878,13 +11938,37 @@
                       <a:r>
                         <a:rPr sz="1763" b="0">
                           <a:solidFill>
+                            <a:srgbClr val="245D8C"/>
+                          </a:solidFill>
+                          <a:latin typeface="Hiragino Sans GB"/>
+                          <a:ea typeface="Hiragino Sans GB"/>
+                          <a:cs typeface="Hiragino Sans GB"/>
+                          <a:hlinkClick xmlns:r="http://schemas.openxmlformats.org/officeDocument/2006/relationships" r:id="Rde59d27a41504c89"/>
+                        </a:rPr>
+                        <a:t>MR-FlowDPO</a:t>
+                      </a:r>
+                      <a:r>
+                        <a:rPr sz="1763" b="0">
+                          <a:solidFill>
                             <a:srgbClr val="202832"/>
                           </a:solidFill>
                           <a:latin typeface="Hiragino Sans GB"/>
                           <a:ea typeface="Hiragino Sans GB"/>
                           <a:cs typeface="Hiragino Sans GB"/>
                         </a:rPr>
-                        <a:t>MR-FlowDPO；VIBE</a:t>
+                        <a:t>；</a:t>
+                      </a:r>
+                      <a:r>
+                        <a:rPr sz="1763" b="0">
+                          <a:solidFill>
+                            <a:srgbClr val="245D8C"/>
+                          </a:solidFill>
+                          <a:latin typeface="Hiragino Sans GB"/>
+                          <a:ea typeface="Hiragino Sans GB"/>
+                          <a:cs typeface="Hiragino Sans GB"/>
+                          <a:hlinkClick xmlns:r="http://schemas.openxmlformats.org/officeDocument/2006/relationships" r:id="Rfbfe9a4e46364fd0"/>
+                        </a:rPr>
+                        <a:t>VIBE</a:t>
                       </a:r>
                     </a:p>
                   </a:txBody>
@@ -12169,30 +12253,66 @@
                       <a:r>
                         <a:rPr sz="1763" b="0">
                           <a:solidFill>
+                            <a:srgbClr val="245D8C"/>
+                          </a:solidFill>
+                          <a:latin typeface="Hiragino Sans GB"/>
+                          <a:ea typeface="Hiragino Sans GB"/>
+                          <a:cs typeface="Hiragino Sans GB"/>
+                          <a:hlinkClick xmlns:r="http://schemas.openxmlformats.org/officeDocument/2006/relationships" r:id="Rab2a93a681834ea8"/>
+                        </a:rPr>
+                        <a:t>Emo-DPO</a:t>
+                      </a:r>
+                      <a:r>
+                        <a:rPr sz="1763" b="0">
+                          <a:solidFill>
                             <a:srgbClr val="202832"/>
                           </a:solidFill>
                           <a:latin typeface="Hiragino Sans GB"/>
                           <a:ea typeface="Hiragino Sans GB"/>
                           <a:cs typeface="Hiragino Sans GB"/>
                         </a:rPr>
-                        <a:t>Emo-DPO；RRPO；</a:t>
-                      </a:r>
-                    </a:p>
-                    <a:p>
-                      <a:pPr algn="l">
-                        <a:lnSpc>
-                          <a:spcPct val="103000"/>
-                        </a:lnSpc>
-                        <a:buNone/>
-                      </a:pPr>
+                        <a:t>；</a:t>
+                      </a:r>
                       <a:r>
                         <a:rPr sz="1763" b="0">
                           <a:solidFill>
+                            <a:srgbClr val="245D8C"/>
+                          </a:solidFill>
+                          <a:latin typeface="Hiragino Sans GB"/>
+                          <a:ea typeface="Hiragino Sans GB"/>
+                          <a:cs typeface="Hiragino Sans GB"/>
+                          <a:hlinkClick xmlns:r="http://schemas.openxmlformats.org/officeDocument/2006/relationships" r:id="R2cf72b11c3b1461c"/>
+                        </a:rPr>
+                        <a:t>RRPO</a:t>
+                      </a:r>
+                      <a:r>
+                        <a:rPr sz="1763" b="0">
+                          <a:solidFill>
                             <a:srgbClr val="202832"/>
                           </a:solidFill>
                           <a:latin typeface="Hiragino Sans GB"/>
                           <a:ea typeface="Hiragino Sans GB"/>
                           <a:cs typeface="Hiragino Sans GB"/>
+                        </a:rPr>
+                        <a:t>；</a:t>
+                      </a:r>
+                    </a:p>
+                    <a:p>
+                      <a:pPr algn="l">
+                        <a:lnSpc>
+                          <a:spcPct val="103000"/>
+                        </a:lnSpc>
+                        <a:buNone/>
+                      </a:pPr>
+                      <a:r>
+                        <a:rPr sz="1763" b="0">
+                          <a:solidFill>
+                            <a:srgbClr val="245D8C"/>
+                          </a:solidFill>
+                          <a:latin typeface="Hiragino Sans GB"/>
+                          <a:ea typeface="Hiragino Sans GB"/>
+                          <a:cs typeface="Hiragino Sans GB"/>
+                          <a:hlinkClick xmlns:r="http://schemas.openxmlformats.org/officeDocument/2006/relationships" r:id="R5abd94a1bdae4a2b"/>
                         </a:rPr>
                         <a:t>Emotion-Director</a:t>
                       </a:r>
@@ -12479,30 +12599,66 @@
                       <a:r>
                         <a:rPr sz="1763" b="0">
                           <a:solidFill>
+                            <a:srgbClr val="245D8C"/>
+                          </a:solidFill>
+                          <a:latin typeface="Hiragino Sans GB"/>
+                          <a:ea typeface="Hiragino Sans GB"/>
+                          <a:cs typeface="Hiragino Sans GB"/>
+                          <a:hlinkClick xmlns:r="http://schemas.openxmlformats.org/officeDocument/2006/relationships" r:id="R4ac4a2c732db4cc3"/>
+                        </a:rPr>
+                        <a:t>LeVo 2</a:t>
+                      </a:r>
+                      <a:r>
+                        <a:rPr sz="1763" b="0">
+                          <a:solidFill>
                             <a:srgbClr val="202832"/>
                           </a:solidFill>
                           <a:latin typeface="Hiragino Sans GB"/>
                           <a:ea typeface="Hiragino Sans GB"/>
                           <a:cs typeface="Hiragino Sans GB"/>
                         </a:rPr>
-                        <a:t>LeVo 2；FullSong；</a:t>
-                      </a:r>
-                    </a:p>
-                    <a:p>
-                      <a:pPr algn="l">
-                        <a:lnSpc>
-                          <a:spcPct val="103000"/>
-                        </a:lnSpc>
-                        <a:buNone/>
-                      </a:pPr>
+                        <a:t>；</a:t>
+                      </a:r>
                       <a:r>
                         <a:rPr sz="1763" b="0">
                           <a:solidFill>
+                            <a:srgbClr val="245D8C"/>
+                          </a:solidFill>
+                          <a:latin typeface="Hiragino Sans GB"/>
+                          <a:ea typeface="Hiragino Sans GB"/>
+                          <a:cs typeface="Hiragino Sans GB"/>
+                          <a:hlinkClick xmlns:r="http://schemas.openxmlformats.org/officeDocument/2006/relationships" r:id="R50034944b69549af"/>
+                        </a:rPr>
+                        <a:t>FullSong</a:t>
+                      </a:r>
+                      <a:r>
+                        <a:rPr sz="1763" b="0">
+                          <a:solidFill>
                             <a:srgbClr val="202832"/>
                           </a:solidFill>
                           <a:latin typeface="Hiragino Sans GB"/>
                           <a:ea typeface="Hiragino Sans GB"/>
                           <a:cs typeface="Hiragino Sans GB"/>
+                        </a:rPr>
+                        <a:t>；</a:t>
+                      </a:r>
+                    </a:p>
+                    <a:p>
+                      <a:pPr algn="l">
+                        <a:lnSpc>
+                          <a:spcPct val="103000"/>
+                        </a:lnSpc>
+                        <a:buNone/>
+                      </a:pPr>
+                      <a:r>
+                        <a:rPr sz="1763" b="0">
+                          <a:solidFill>
+                            <a:srgbClr val="245D8C"/>
+                          </a:solidFill>
+                          <a:latin typeface="Hiragino Sans GB"/>
+                          <a:ea typeface="Hiragino Sans GB"/>
+                          <a:cs typeface="Hiragino Sans GB"/>
+                          <a:hlinkClick xmlns:r="http://schemas.openxmlformats.org/officeDocument/2006/relationships" r:id="R289fac60674d43c0"/>
                         </a:rPr>
                         <a:t>SongBloom扩展</a:t>
                       </a:r>
@@ -12789,30 +12945,66 @@
                       <a:r>
                         <a:rPr sz="1763" b="0">
                           <a:solidFill>
+                            <a:srgbClr val="245D8C"/>
+                          </a:solidFill>
+                          <a:latin typeface="Hiragino Sans GB"/>
+                          <a:ea typeface="Hiragino Sans GB"/>
+                          <a:cs typeface="Hiragino Sans GB"/>
+                          <a:hlinkClick xmlns:r="http://schemas.openxmlformats.org/officeDocument/2006/relationships" r:id="Rb1a9078fc27546e5"/>
+                        </a:rPr>
+                        <a:t>MusicRL</a:t>
+                      </a:r>
+                      <a:r>
+                        <a:rPr sz="1763" b="0">
+                          <a:solidFill>
                             <a:srgbClr val="202832"/>
                           </a:solidFill>
                           <a:latin typeface="Hiragino Sans GB"/>
                           <a:ea typeface="Hiragino Sans GB"/>
                           <a:cs typeface="Hiragino Sans GB"/>
                         </a:rPr>
-                        <a:t>MusicRL；MuseCritic；</a:t>
-                      </a:r>
-                    </a:p>
-                    <a:p>
-                      <a:pPr algn="l">
-                        <a:lnSpc>
-                          <a:spcPct val="103000"/>
-                        </a:lnSpc>
-                        <a:buNone/>
-                      </a:pPr>
+                        <a:t>；</a:t>
+                      </a:r>
                       <a:r>
                         <a:rPr sz="1763" b="0">
                           <a:solidFill>
+                            <a:srgbClr val="245D8C"/>
+                          </a:solidFill>
+                          <a:latin typeface="Hiragino Sans GB"/>
+                          <a:ea typeface="Hiragino Sans GB"/>
+                          <a:cs typeface="Hiragino Sans GB"/>
+                          <a:hlinkClick xmlns:r="http://schemas.openxmlformats.org/officeDocument/2006/relationships" r:id="R10c4bf1439f244ba"/>
+                        </a:rPr>
+                        <a:t>MuseCritic</a:t>
+                      </a:r>
+                      <a:r>
+                        <a:rPr sz="1763" b="0">
+                          <a:solidFill>
                             <a:srgbClr val="202832"/>
                           </a:solidFill>
                           <a:latin typeface="Hiragino Sans GB"/>
                           <a:ea typeface="Hiragino Sans GB"/>
                           <a:cs typeface="Hiragino Sans GB"/>
+                        </a:rPr>
+                        <a:t>；</a:t>
+                      </a:r>
+                    </a:p>
+                    <a:p>
+                      <a:pPr algn="l">
+                        <a:lnSpc>
+                          <a:spcPct val="103000"/>
+                        </a:lnSpc>
+                        <a:buNone/>
+                      </a:pPr>
+                      <a:r>
+                        <a:rPr sz="1763" b="0">
+                          <a:solidFill>
+                            <a:srgbClr val="245D8C"/>
+                          </a:solidFill>
+                          <a:latin typeface="Hiragino Sans GB"/>
+                          <a:ea typeface="Hiragino Sans GB"/>
+                          <a:cs typeface="Hiragino Sans GB"/>
+                          <a:hlinkClick xmlns:r="http://schemas.openxmlformats.org/officeDocument/2006/relationships" r:id="R1875738c66bd4153"/>
                         </a:rPr>
                         <a:t>WanSong</a:t>
                       </a:r>
@@ -13124,7 +13316,19 @@
                           <a:ea typeface="Hiragino Sans GB"/>
                           <a:cs typeface="Hiragino Sans GB"/>
                         </a:rPr>
-                        <a:t>可借多维音乐奖励</a:t>
+                        <a:t>可借</a:t>
+                      </a:r>
+                      <a:r>
+                        <a:rPr sz="1763" b="0">
+                          <a:solidFill>
+                            <a:srgbClr val="245D8C"/>
+                          </a:solidFill>
+                          <a:latin typeface="Hiragino Sans GB"/>
+                          <a:ea typeface="Hiragino Sans GB"/>
+                          <a:cs typeface="Hiragino Sans GB"/>
+                          <a:hlinkClick xmlns:r="http://schemas.openxmlformats.org/officeDocument/2006/relationships" r:id="Rf5b2a940e7204fe2"/>
+                        </a:rPr>
+                        <a:t>多维音乐奖励</a:t>
                       </a:r>
                     </a:p>
                   </a:txBody>
@@ -13390,13 +13594,25 @@
                       <a:r>
                         <a:rPr sz="1763" b="0">
                           <a:solidFill>
+                            <a:srgbClr val="245D8C"/>
+                          </a:solidFill>
+                          <a:latin typeface="Hiragino Sans GB"/>
+                          <a:ea typeface="Hiragino Sans GB"/>
+                          <a:cs typeface="Hiragino Sans GB"/>
+                          <a:hlinkClick xmlns:r="http://schemas.openxmlformats.org/officeDocument/2006/relationships" r:id="Rf091a1e428c74b6d"/>
+                        </a:rPr>
+                        <a:t>YingMusic-Singer</a:t>
+                      </a:r>
+                      <a:r>
+                        <a:rPr sz="1763" b="0">
+                          <a:solidFill>
                             <a:srgbClr val="202832"/>
                           </a:solidFill>
                           <a:latin typeface="Hiragino Sans GB"/>
                           <a:ea typeface="Hiragino Sans GB"/>
                           <a:cs typeface="Hiragino Sans GB"/>
                         </a:rPr>
-                        <a:t>YingMusic-Singer歌词编辑</a:t>
+                        <a:t>歌词编辑</a:t>
                       </a:r>
                     </a:p>
                   </a:txBody>
@@ -13681,13 +13897,25 @@
                       <a:r>
                         <a:rPr sz="1763" b="0">
                           <a:solidFill>
+                            <a:srgbClr val="245D8C"/>
+                          </a:solidFill>
+                          <a:latin typeface="Hiragino Sans GB"/>
+                          <a:ea typeface="Hiragino Sans GB"/>
+                          <a:cs typeface="Hiragino Sans GB"/>
+                          <a:hlinkClick xmlns:r="http://schemas.openxmlformats.org/officeDocument/2006/relationships" r:id="R064b57226c3241f2"/>
+                        </a:rPr>
+                        <a:t>MusicRL</a:t>
+                      </a:r>
+                      <a:r>
+                        <a:rPr sz="1763" b="0">
+                          <a:solidFill>
                             <a:srgbClr val="202832"/>
                           </a:solidFill>
                           <a:latin typeface="Hiragino Sans GB"/>
                           <a:ea typeface="Hiragino Sans GB"/>
                           <a:cs typeface="Hiragino Sans GB"/>
                         </a:rPr>
-                        <a:t>MusicRL群体偏好对齐</a:t>
+                        <a:t>群体偏好对齐</a:t>
                       </a:r>
                     </a:p>
                   </a:txBody>
@@ -13953,13 +14181,25 @@
                       <a:r>
                         <a:rPr sz="1763" b="0">
                           <a:solidFill>
+                            <a:srgbClr val="245D8C"/>
+                          </a:solidFill>
+                          <a:latin typeface="Hiragino Sans GB"/>
+                          <a:ea typeface="Hiragino Sans GB"/>
+                          <a:cs typeface="Hiragino Sans GB"/>
+                          <a:hlinkClick xmlns:r="http://schemas.openxmlformats.org/officeDocument/2006/relationships" r:id="R676a379d9b4e46d1"/>
+                        </a:rPr>
+                        <a:t>VIBE</a:t>
+                      </a:r>
+                      <a:r>
+                        <a:rPr sz="1763" b="0">
+                          <a:solidFill>
                             <a:srgbClr val="202832"/>
                           </a:solidFill>
                           <a:latin typeface="Hiragino Sans GB"/>
                           <a:ea typeface="Hiragino Sans GB"/>
                           <a:cs typeface="Hiragino Sans GB"/>
                         </a:rPr>
-                        <a:t>VIBE视频背景音乐</a:t>
+                        <a:t>视频背景音乐</a:t>
                       </a:r>
                     </a:p>
                   </a:txBody>
@@ -14638,7 +14878,7 @@
           <p:cNvPr id="5" name="">
             <a:extLst xmlns:a="http://schemas.openxmlformats.org/drawingml/2006/main">
               <a:ext uri="{FF2B5EF4-FFF2-40B4-BE49-F238E27FC236}">
-                <a16:creationId xmlns:a16="http://schemas.microsoft.com/office/drawing/2014/main" id="{12C51211-37F1-44D7-B88B-7394A271DC59}"/>
+                <a16:creationId xmlns:a16="http://schemas.microsoft.com/office/drawing/2014/main" id="{B5E0D784-FBB4-449B-9075-CA8E3060DE5A}"/>
               </a:ext>
             </a:extLst>
           </p:cNvPr>
@@ -15080,13 +15320,37 @@
                       <a:r>
                         <a:rPr sz="1594" b="0">
                           <a:solidFill>
+                            <a:srgbClr val="245D8C"/>
+                          </a:solidFill>
+                          <a:latin typeface="Hiragino Sans GB"/>
+                          <a:ea typeface="Hiragino Sans GB"/>
+                          <a:cs typeface="Hiragino Sans GB"/>
+                          <a:hlinkClick xmlns:r="http://schemas.openxmlformats.org/officeDocument/2006/relationships" r:id="R9a6567e39b784506"/>
+                        </a:rPr>
+                        <a:t>ImageReward</a:t>
+                      </a:r>
+                      <a:r>
+                        <a:rPr sz="1594" b="0">
+                          <a:solidFill>
                             <a:srgbClr val="202832"/>
                           </a:solidFill>
                           <a:latin typeface="Hiragino Sans GB"/>
                           <a:ea typeface="Hiragino Sans GB"/>
                           <a:cs typeface="Hiragino Sans GB"/>
                         </a:rPr>
-                        <a:t>ImageReward / ReFL</a:t>
+                        <a:t> / </a:t>
+                      </a:r>
+                      <a:r>
+                        <a:rPr sz="1594" b="0">
+                          <a:solidFill>
+                            <a:srgbClr val="245D8C"/>
+                          </a:solidFill>
+                          <a:latin typeface="Hiragino Sans GB"/>
+                          <a:ea typeface="Hiragino Sans GB"/>
+                          <a:cs typeface="Hiragino Sans GB"/>
+                          <a:hlinkClick xmlns:r="http://schemas.openxmlformats.org/officeDocument/2006/relationships" r:id="R3ea34dcb4e904b8c"/>
+                        </a:rPr>
+                        <a:t>ReFL</a:t>
                       </a:r>
                     </a:p>
                   </a:txBody>
@@ -15352,11 +15616,12 @@
                       <a:r>
                         <a:rPr sz="1594" b="0">
                           <a:solidFill>
-                            <a:srgbClr val="202832"/>
-                          </a:solidFill>
-                          <a:latin typeface="Hiragino Sans GB"/>
-                          <a:ea typeface="Hiragino Sans GB"/>
-                          <a:cs typeface="Hiragino Sans GB"/>
+                            <a:srgbClr val="245D8C"/>
+                          </a:solidFill>
+                          <a:latin typeface="Hiragino Sans GB"/>
+                          <a:ea typeface="Hiragino Sans GB"/>
+                          <a:cs typeface="Hiragino Sans GB"/>
+                          <a:hlinkClick xmlns:r="http://schemas.openxmlformats.org/officeDocument/2006/relationships" r:id="R56e952feacb54c50"/>
                         </a:rPr>
                         <a:t>DDPO</a:t>
                       </a:r>
@@ -15624,11 +15889,12 @@
                       <a:r>
                         <a:rPr sz="1594" b="0">
                           <a:solidFill>
-                            <a:srgbClr val="202832"/>
-                          </a:solidFill>
-                          <a:latin typeface="Hiragino Sans GB"/>
-                          <a:ea typeface="Hiragino Sans GB"/>
-                          <a:cs typeface="Hiragino Sans GB"/>
+                            <a:srgbClr val="245D8C"/>
+                          </a:solidFill>
+                          <a:latin typeface="Hiragino Sans GB"/>
+                          <a:ea typeface="Hiragino Sans GB"/>
+                          <a:cs typeface="Hiragino Sans GB"/>
+                          <a:hlinkClick xmlns:r="http://schemas.openxmlformats.org/officeDocument/2006/relationships" r:id="Rb851b1ea04b6450c"/>
                         </a:rPr>
                         <a:t>Diffusion-DPO</a:t>
                       </a:r>
@@ -15896,13 +16162,25 @@
                       <a:r>
                         <a:rPr sz="1594" b="0">
                           <a:solidFill>
+                            <a:srgbClr val="245D8C"/>
+                          </a:solidFill>
+                          <a:latin typeface="Hiragino Sans GB"/>
+                          <a:ea typeface="Hiragino Sans GB"/>
+                          <a:cs typeface="Hiragino Sans GB"/>
+                          <a:hlinkClick xmlns:r="http://schemas.openxmlformats.org/officeDocument/2006/relationships" r:id="R0c1b8719960f4521"/>
+                        </a:rPr>
+                        <a:t>Flow-GRPO</a:t>
+                      </a:r>
+                      <a:r>
+                        <a:rPr sz="1594" b="0">
+                          <a:solidFill>
                             <a:srgbClr val="202832"/>
                           </a:solidFill>
                           <a:latin typeface="Hiragino Sans GB"/>
                           <a:ea typeface="Hiragino Sans GB"/>
                           <a:cs typeface="Hiragino Sans GB"/>
                         </a:rPr>
-                        <a:t>Flow-GRPO /</a:t>
+                        <a:t> /</a:t>
                       </a:r>
                     </a:p>
                     <a:p>
@@ -15915,11 +16193,12 @@
                       <a:r>
                         <a:rPr sz="1594" b="0">
                           <a:solidFill>
-                            <a:srgbClr val="202832"/>
-                          </a:solidFill>
-                          <a:latin typeface="Hiragino Sans GB"/>
-                          <a:ea typeface="Hiragino Sans GB"/>
-                          <a:cs typeface="Hiragino Sans GB"/>
+                            <a:srgbClr val="245D8C"/>
+                          </a:solidFill>
+                          <a:latin typeface="Hiragino Sans GB"/>
+                          <a:ea typeface="Hiragino Sans GB"/>
+                          <a:cs typeface="Hiragino Sans GB"/>
+                          <a:hlinkClick xmlns:r="http://schemas.openxmlformats.org/officeDocument/2006/relationships" r:id="R67b33c760c43436a"/>
                         </a:rPr>
                         <a:t>GRPO-Guard</a:t>
                       </a:r>
@@ -16187,13 +16466,58 @@
                       <a:r>
                         <a:rPr sz="1594" b="0">
                           <a:solidFill>
+                            <a:srgbClr val="245D8C"/>
+                          </a:solidFill>
+                          <a:latin typeface="Hiragino Sans GB"/>
+                          <a:ea typeface="Hiragino Sans GB"/>
+                          <a:cs typeface="Hiragino Sans GB"/>
+                          <a:hlinkClick xmlns:r="http://schemas.openxmlformats.org/officeDocument/2006/relationships" r:id="Ra13deaf0814b4cde"/>
+                        </a:rPr>
+                        <a:t>DiffusionNFT</a:t>
+                      </a:r>
+                    </a:p>
+                  </a:txBody>
+                  <a:tcPr marL="114300" marR="114300" marT="66675" marB="66675" anchor="ctr">
+                    <a:lnR w="0">
+                      <a:solidFill>
+                        <a:srgbClr val="FFFFFF"/>
+                      </a:solidFill>
+                      <a:prstDash val="solid"/>
+                    </a:lnR>
+                    <a:lnB w="0">
+                      <a:solidFill>
+                        <a:srgbClr val="FFFFFF"/>
+                      </a:solidFill>
+                      <a:prstDash val="solid"/>
+                    </a:lnB>
+                    <a:solidFill>
+                      <a:srgbClr val="FFFFFF"/>
+                    </a:solidFill>
+                  </a:tcPr>
+                </a:tc>
+                <a:tc>
+                  <a:txBody>
+                    <a:bodyPr wrap="none">
+                      <a:noAutofit/>
+                    </a:bodyPr>
+                    <a:lstStyle/>
+                    <a:p>
+                      <a:pPr algn="l">
+                        <a:lnSpc>
+                          <a:spcPct val="103000"/>
+                        </a:lnSpc>
+                        <a:buNone/>
+                      </a:pPr>
+                      <a:r>
+                        <a:rPr sz="1594" b="0">
+                          <a:solidFill>
                             <a:srgbClr val="202832"/>
                           </a:solidFill>
                           <a:latin typeface="Hiragino Sans GB"/>
                           <a:ea typeface="Hiragino Sans GB"/>
                           <a:cs typeface="Hiragino Sans GB"/>
                         </a:rPr>
-                        <a:t>DiffusionNFT</a:t>
+                        <a:t>最终样本的黑盒评分</a:t>
                       </a:r>
                     </a:p>
                   </a:txBody>
@@ -16237,34 +16561,9 @@
                           <a:ea typeface="Hiragino Sans GB"/>
                           <a:cs typeface="Hiragino Sans GB"/>
                         </a:rPr>
-                        <a:t>最终样本的黑盒评分</a:t>
-                      </a:r>
-                    </a:p>
-                  </a:txBody>
-                  <a:tcPr marL="114300" marR="114300" marT="66675" marB="66675" anchor="ctr">
-                    <a:lnR w="0">
-                      <a:solidFill>
-                        <a:srgbClr val="FFFFFF"/>
-                      </a:solidFill>
-                      <a:prstDash val="solid"/>
-                    </a:lnR>
-                    <a:lnB w="0">
-                      <a:solidFill>
-                        <a:srgbClr val="FFFFFF"/>
-                      </a:solidFill>
-                      <a:prstDash val="solid"/>
-                    </a:lnB>
-                    <a:solidFill>
-                      <a:srgbClr val="FFFFFF"/>
-                    </a:solidFill>
-                  </a:tcPr>
-                </a:tc>
-                <a:tc>
-                  <a:txBody>
-                    <a:bodyPr wrap="none">
-                      <a:noAutofit/>
-                    </a:bodyPr>
-                    <a:lstStyle/>
+                        <a:t>多任务＋人评；音乐另看</a:t>
+                      </a:r>
+                    </a:p>
                     <a:p>
                       <a:pPr algn="l">
                         <a:lnSpc>
@@ -16275,30 +16574,12 @@
                       <a:r>
                         <a:rPr sz="1594" b="0">
                           <a:solidFill>
-                            <a:srgbClr val="202832"/>
-                          </a:solidFill>
-                          <a:latin typeface="Hiragino Sans GB"/>
-                          <a:ea typeface="Hiragino Sans GB"/>
-                          <a:cs typeface="Hiragino Sans GB"/>
-                        </a:rPr>
-                        <a:t>多任务＋人评；音乐另看</a:t>
-                      </a:r>
-                    </a:p>
-                    <a:p>
-                      <a:pPr algn="l">
-                        <a:lnSpc>
-                          <a:spcPct val="103000"/>
-                        </a:lnSpc>
-                        <a:buNone/>
-                      </a:pPr>
-                      <a:r>
-                        <a:rPr sz="1594" b="0">
-                          <a:solidFill>
-                            <a:srgbClr val="202832"/>
-                          </a:solidFill>
-                          <a:latin typeface="Hiragino Sans GB"/>
-                          <a:ea typeface="Hiragino Sans GB"/>
-                          <a:cs typeface="Hiragino Sans GB"/>
+                            <a:srgbClr val="245D8C"/>
+                          </a:solidFill>
+                          <a:latin typeface="Hiragino Sans GB"/>
+                          <a:ea typeface="Hiragino Sans GB"/>
+                          <a:cs typeface="Hiragino Sans GB"/>
+                          <a:hlinkClick xmlns:r="http://schemas.openxmlformats.org/officeDocument/2006/relationships" r:id="Rd54eff15c80346e4"/>
                         </a:rPr>
                         <a:t>VIBE</a:t>
                       </a:r>
@@ -16478,30 +16759,66 @@
                       <a:r>
                         <a:rPr sz="1594" b="0">
                           <a:solidFill>
+                            <a:srgbClr val="245D8C"/>
+                          </a:solidFill>
+                          <a:latin typeface="Hiragino Sans GB"/>
+                          <a:ea typeface="Hiragino Sans GB"/>
+                          <a:cs typeface="Hiragino Sans GB"/>
+                          <a:hlinkClick xmlns:r="http://schemas.openxmlformats.org/officeDocument/2006/relationships" r:id="R5e3e3d6deaa84859"/>
+                        </a:rPr>
+                        <a:t>UNO</a:t>
+                      </a:r>
+                      <a:r>
+                        <a:rPr sz="1594" b="0">
+                          <a:solidFill>
                             <a:srgbClr val="202832"/>
                           </a:solidFill>
                           <a:latin typeface="Hiragino Sans GB"/>
                           <a:ea typeface="Hiragino Sans GB"/>
                           <a:cs typeface="Hiragino Sans GB"/>
                         </a:rPr>
-                        <a:t>UNO / Emo-DPO /</a:t>
-                      </a:r>
-                    </a:p>
-                    <a:p>
-                      <a:pPr algn="l">
-                        <a:lnSpc>
-                          <a:spcPct val="103000"/>
-                        </a:lnSpc>
-                        <a:buNone/>
-                      </a:pPr>
+                        <a:t> / </a:t>
+                      </a:r>
                       <a:r>
                         <a:rPr sz="1594" b="0">
                           <a:solidFill>
+                            <a:srgbClr val="245D8C"/>
+                          </a:solidFill>
+                          <a:latin typeface="Hiragino Sans GB"/>
+                          <a:ea typeface="Hiragino Sans GB"/>
+                          <a:cs typeface="Hiragino Sans GB"/>
+                          <a:hlinkClick xmlns:r="http://schemas.openxmlformats.org/officeDocument/2006/relationships" r:id="R2f30cdd13c6041ed"/>
+                        </a:rPr>
+                        <a:t>Emo-DPO</a:t>
+                      </a:r>
+                      <a:r>
+                        <a:rPr sz="1594" b="0">
+                          <a:solidFill>
                             <a:srgbClr val="202832"/>
                           </a:solidFill>
                           <a:latin typeface="Hiragino Sans GB"/>
                           <a:ea typeface="Hiragino Sans GB"/>
                           <a:cs typeface="Hiragino Sans GB"/>
+                        </a:rPr>
+                        <a:t> /</a:t>
+                      </a:r>
+                    </a:p>
+                    <a:p>
+                      <a:pPr algn="l">
+                        <a:lnSpc>
+                          <a:spcPct val="103000"/>
+                        </a:lnSpc>
+                        <a:buNone/>
+                      </a:pPr>
+                      <a:r>
+                        <a:rPr sz="1594" b="0">
+                          <a:solidFill>
+                            <a:srgbClr val="245D8C"/>
+                          </a:solidFill>
+                          <a:latin typeface="Hiragino Sans GB"/>
+                          <a:ea typeface="Hiragino Sans GB"/>
+                          <a:cs typeface="Hiragino Sans GB"/>
+                          <a:hlinkClick xmlns:r="http://schemas.openxmlformats.org/officeDocument/2006/relationships" r:id="Ra244e982796a4c67"/>
                         </a:rPr>
                         <a:t>MPO</a:t>
                       </a:r>
@@ -16769,11 +17086,12 @@
                       <a:r>
                         <a:rPr sz="1594" b="0">
                           <a:solidFill>
-                            <a:srgbClr val="202832"/>
-                          </a:solidFill>
-                          <a:latin typeface="Hiragino Sans GB"/>
-                          <a:ea typeface="Hiragino Sans GB"/>
-                          <a:cs typeface="Hiragino Sans GB"/>
+                            <a:srgbClr val="245D8C"/>
+                          </a:solidFill>
+                          <a:latin typeface="Hiragino Sans GB"/>
+                          <a:ea typeface="Hiragino Sans GB"/>
+                          <a:cs typeface="Hiragino Sans GB"/>
+                          <a:hlinkClick xmlns:r="http://schemas.openxmlformats.org/officeDocument/2006/relationships" r:id="Rc93b1cc467c2459d"/>
                         </a:rPr>
                         <a:t>FPO</a:t>
                       </a:r>
@@ -17041,11 +17359,12 @@
                       <a:r>
                         <a:rPr sz="1594" b="0">
                           <a:solidFill>
-                            <a:srgbClr val="202832"/>
-                          </a:solidFill>
-                          <a:latin typeface="Hiragino Sans GB"/>
-                          <a:ea typeface="Hiragino Sans GB"/>
-                          <a:cs typeface="Hiragino Sans GB"/>
+                            <a:srgbClr val="245D8C"/>
+                          </a:solidFill>
+                          <a:latin typeface="Hiragino Sans GB"/>
+                          <a:ea typeface="Hiragino Sans GB"/>
+                          <a:cs typeface="Hiragino Sans GB"/>
+                          <a:hlinkClick xmlns:r="http://schemas.openxmlformats.org/officeDocument/2006/relationships" r:id="R7e1dfcd244a745e6"/>
                         </a:rPr>
                         <a:t>GSRM</a:t>
                       </a:r>
@@ -17313,11 +17632,12 @@
                       <a:r>
                         <a:rPr sz="1594" b="0">
                           <a:solidFill>
-                            <a:srgbClr val="202832"/>
-                          </a:solidFill>
-                          <a:latin typeface="Hiragino Sans GB"/>
-                          <a:ea typeface="Hiragino Sans GB"/>
-                          <a:cs typeface="Hiragino Sans GB"/>
+                            <a:srgbClr val="245D8C"/>
+                          </a:solidFill>
+                          <a:latin typeface="Hiragino Sans GB"/>
+                          <a:ea typeface="Hiragino Sans GB"/>
+                          <a:cs typeface="Hiragino Sans GB"/>
+                          <a:hlinkClick xmlns:r="http://schemas.openxmlformats.org/officeDocument/2006/relationships" r:id="Ra9e6ae14529a4900"/>
                         </a:rPr>
                         <a:t>Perceptual Rewards</a:t>
                       </a:r>
@@ -17585,11 +17905,12 @@
                       <a:r>
                         <a:rPr sz="1594" b="0">
                           <a:solidFill>
-                            <a:srgbClr val="202832"/>
-                          </a:solidFill>
-                          <a:latin typeface="Hiragino Sans GB"/>
-                          <a:ea typeface="Hiragino Sans GB"/>
-                          <a:cs typeface="Hiragino Sans GB"/>
+                            <a:srgbClr val="245D8C"/>
+                          </a:solidFill>
+                          <a:latin typeface="Hiragino Sans GB"/>
+                          <a:ea typeface="Hiragino Sans GB"/>
+                          <a:cs typeface="Hiragino Sans GB"/>
+                          <a:hlinkClick xmlns:r="http://schemas.openxmlformats.org/officeDocument/2006/relationships" r:id="R07fb08e39c004361"/>
                         </a:rPr>
                         <a:t>DLPO</a:t>
                       </a:r>
@@ -17857,13 +18178,37 @@
                       <a:r>
                         <a:rPr sz="1594" b="0">
                           <a:solidFill>
+                            <a:srgbClr val="245D8C"/>
+                          </a:solidFill>
+                          <a:latin typeface="Hiragino Sans GB"/>
+                          <a:ea typeface="Hiragino Sans GB"/>
+                          <a:cs typeface="Hiragino Sans GB"/>
+                          <a:hlinkClick xmlns:r="http://schemas.openxmlformats.org/officeDocument/2006/relationships" r:id="R4e892f3da347477d"/>
+                        </a:rPr>
+                        <a:t>DiffRO</a:t>
+                      </a:r>
+                      <a:r>
+                        <a:rPr sz="1594" b="0">
+                          <a:solidFill>
                             <a:srgbClr val="202832"/>
                           </a:solidFill>
                           <a:latin typeface="Hiragino Sans GB"/>
                           <a:ea typeface="Hiragino Sans GB"/>
                           <a:cs typeface="Hiragino Sans GB"/>
                         </a:rPr>
-                        <a:t>DiffRO / RRPO</a:t>
+                        <a:t> / </a:t>
+                      </a:r>
+                      <a:r>
+                        <a:rPr sz="1594" b="0">
+                          <a:solidFill>
+                            <a:srgbClr val="245D8C"/>
+                          </a:solidFill>
+                          <a:latin typeface="Hiragino Sans GB"/>
+                          <a:ea typeface="Hiragino Sans GB"/>
+                          <a:cs typeface="Hiragino Sans GB"/>
+                          <a:hlinkClick xmlns:r="http://schemas.openxmlformats.org/officeDocument/2006/relationships" r:id="R2dbbedad4d9c4715"/>
+                        </a:rPr>
+                        <a:t>RRPO</a:t>
                       </a:r>
                     </a:p>
                   </a:txBody>
@@ -18129,11 +18474,12 @@
                       <a:r>
                         <a:rPr sz="1594" b="0">
                           <a:solidFill>
-                            <a:srgbClr val="202832"/>
-                          </a:solidFill>
-                          <a:latin typeface="Hiragino Sans GB"/>
-                          <a:ea typeface="Hiragino Sans GB"/>
-                          <a:cs typeface="Hiragino Sans GB"/>
+                            <a:srgbClr val="245D8C"/>
+                          </a:solidFill>
+                          <a:latin typeface="Hiragino Sans GB"/>
+                          <a:ea typeface="Hiragino Sans GB"/>
+                          <a:cs typeface="Hiragino Sans GB"/>
+                          <a:hlinkClick xmlns:r="http://schemas.openxmlformats.org/officeDocument/2006/relationships" r:id="R9cd6afc7e7e54345"/>
                         </a:rPr>
                         <a:t>YingMusic-Singer系列</a:t>
                       </a:r>
@@ -18401,11 +18747,12 @@
                       <a:r>
                         <a:rPr sz="1594" b="0">
                           <a:solidFill>
-                            <a:srgbClr val="202832"/>
-                          </a:solidFill>
-                          <a:latin typeface="Hiragino Sans GB"/>
-                          <a:ea typeface="Hiragino Sans GB"/>
-                          <a:cs typeface="Hiragino Sans GB"/>
+                            <a:srgbClr val="245D8C"/>
+                          </a:solidFill>
+                          <a:latin typeface="Hiragino Sans GB"/>
+                          <a:ea typeface="Hiragino Sans GB"/>
+                          <a:cs typeface="Hiragino Sans GB"/>
+                          <a:hlinkClick xmlns:r="http://schemas.openxmlformats.org/officeDocument/2006/relationships" r:id="R5f8a8a37c67c4299"/>
                         </a:rPr>
                         <a:t>S²Voice</a:t>
                       </a:r>
@@ -18673,11 +19020,12 @@
                       <a:r>
                         <a:rPr sz="1594" b="0">
                           <a:solidFill>
-                            <a:srgbClr val="202832"/>
-                          </a:solidFill>
-                          <a:latin typeface="Hiragino Sans GB"/>
-                          <a:ea typeface="Hiragino Sans GB"/>
-                          <a:cs typeface="Hiragino Sans GB"/>
+                            <a:srgbClr val="245D8C"/>
+                          </a:solidFill>
+                          <a:latin typeface="Hiragino Sans GB"/>
+                          <a:ea typeface="Hiragino Sans GB"/>
+                          <a:cs typeface="Hiragino Sans GB"/>
+                          <a:hlinkClick xmlns:r="http://schemas.openxmlformats.org/officeDocument/2006/relationships" r:id="Rc41c9a3548da499e"/>
                         </a:rPr>
                         <a:t>VocalCritic</a:t>
                       </a:r>
@@ -18906,7 +19254,42 @@
                 <a:ea typeface="Hiragino Sans GB"/>
                 <a:cs typeface="Hiragino Sans GB"/>
               </a:rPr>
-              <a:t>主观反馈与ASR、F0等弱可验证代理分开。目标分升高需要用独立听评确认。</a:t>
+              <a:t>主观反馈与ASR、F0等弱可验证代理分开。目标分升高需要用独立听评确认。  YingMusic-Singer论文：</a:t>
+            </a:r>
+            <a:r>
+              <a:rPr sz="1410" b="0">
+                <a:solidFill>
+                  <a:srgbClr val="245D8C"/>
+                </a:solidFill>
+                <a:latin typeface="Hiragino Sans GB"/>
+                <a:ea typeface="Hiragino Sans GB"/>
+                <a:cs typeface="Hiragino Sans GB"/>
+                <a:hlinkClick xmlns:r="http://schemas.openxmlformats.org/officeDocument/2006/relationships" r:id="Rc3ac84e78ccb44ab"/>
+              </a:rPr>
+              <a:t>2025</a:t>
+            </a:r>
+            <a:r>
+              <a:rPr sz="1410" b="0">
+                <a:solidFill>
+                  <a:srgbClr val="6A737B"/>
+                </a:solidFill>
+                <a:latin typeface="Hiragino Sans GB"/>
+                <a:ea typeface="Hiragino Sans GB"/>
+                <a:cs typeface="Hiragino Sans GB"/>
+              </a:rPr>
+              <a:t> / </a:t>
+            </a:r>
+            <a:r>
+              <a:rPr sz="1410" b="0">
+                <a:solidFill>
+                  <a:srgbClr val="245D8C"/>
+                </a:solidFill>
+                <a:latin typeface="Hiragino Sans GB"/>
+                <a:ea typeface="Hiragino Sans GB"/>
+                <a:cs typeface="Hiragino Sans GB"/>
+                <a:hlinkClick xmlns:r="http://schemas.openxmlformats.org/officeDocument/2006/relationships" r:id="R4f8f48c500b6498e"/>
+              </a:rPr>
+              <a:t>2026</a:t>
             </a:r>
           </a:p>
         </p:txBody>

</xml_diff>